<commit_message>
fix: patch SEBI footer spacing to prevent LibreOffice PDF wrap overflow and update upload views
</commit_message>
<xml_diff>
--- a/master_template.pptx
+++ b/master_template.pptx
@@ -12352,7 +12352,7 @@
                 <a:cs typeface="Calibri"/>
                 <a:sym typeface="Calibri"/>
               </a:rPr>
-              <a:t>SEBI Reg. INH000009807                                                                                                                                                                                                                                                          </a:t>
+              <a:t>SEBI Reg. INH000009807</a:t>
             </a:r>
             <a:endParaRPr sz="800" b="0" i="0" u="none" strike="noStrike" cap="none" dirty="0">
               <a:solidFill>
@@ -13863,7 +13863,7 @@
                 <a:cs typeface="Calibri"/>
                 <a:sym typeface="Calibri"/>
               </a:rPr>
-              <a:t>SEBI Reg. INH000009807                                                                                                                                                                                                                                                          </a:t>
+              <a:t>SEBI Reg. INH000009807</a:t>
             </a:r>
             <a:endParaRPr sz="800" b="0" i="0" u="none" strike="noStrike" cap="none">
               <a:solidFill>
@@ -16031,7 +16031,7 @@
                 <a:cs typeface="Calibri"/>
                 <a:sym typeface="Calibri"/>
               </a:rPr>
-              <a:t>SEBI Reg. INH000009807                                                                                                                                                                                                                                                          </a:t>
+              <a:t>SEBI Reg. INH000009807</a:t>
             </a:r>
             <a:endParaRPr sz="800" b="0" i="0" u="none" strike="noStrike" cap="none">
               <a:solidFill>
@@ -17507,7 +17507,7 @@
                 <a:cs typeface="Calibri"/>
                 <a:sym typeface="Calibri"/>
               </a:rPr>
-              <a:t>SEBI Reg. INH000009807                                                                                                                                                                                                                                                          </a:t>
+              <a:t>SEBI Reg. INH000009807</a:t>
             </a:r>
             <a:endParaRPr sz="800" b="0" i="0" u="none" strike="noStrike" cap="none">
               <a:solidFill>
@@ -17934,7 +17934,7 @@
                 <a:cs typeface="Calibri"/>
                 <a:sym typeface="Calibri"/>
               </a:rPr>
-              <a:t>SEBI Reg. INH000009807                                                                                                                                                                                                                                                          </a:t>
+              <a:t>SEBI Reg. INH000009807</a:t>
             </a:r>
             <a:endParaRPr sz="800" b="0" i="0" u="none" strike="noStrike" cap="none">
               <a:solidFill>
@@ -18761,7 +18761,7 @@
                 <a:cs typeface="Calibri"/>
                 <a:sym typeface="Calibri"/>
               </a:rPr>
-              <a:t>SEBI Reg. INH000009807                                                                                                                                                                                                                                                          </a:t>
+              <a:t>SEBI Reg. INH000009807</a:t>
             </a:r>
             <a:endParaRPr sz="800" b="0" i="0" u="none" strike="noStrike" cap="none">
               <a:solidFill>
@@ -19358,7 +19358,7 @@
                 <a:cs typeface="Calibri"/>
                 <a:sym typeface="Calibri"/>
               </a:rPr>
-              <a:t>SEBI Reg. INH000009807                                                                                                                                                                                                                                                          </a:t>
+              <a:t>SEBI Reg. INH000009807</a:t>
             </a:r>
             <a:endParaRPr sz="800" b="0" i="0" u="none" strike="noStrike" cap="none">
               <a:solidFill>
@@ -21641,7 +21641,7 @@
                 <a:cs typeface="Calibri"/>
                 <a:sym typeface="Calibri"/>
               </a:rPr>
-              <a:t>SEBI Reg. INH000009807                                                                                                                                                                                                                                                          </a:t>
+              <a:t>SEBI Reg. INH000009807</a:t>
             </a:r>
             <a:endParaRPr sz="800" b="0" i="0" u="none" strike="noStrike" cap="none">
               <a:solidFill>
@@ -24151,7 +24151,7 @@
                 <a:cs typeface="Calibri"/>
                 <a:sym typeface="Calibri"/>
               </a:rPr>
-              <a:t>SEBI Reg. INH000009807                                                                                                                                                                                                                                                          </a:t>
+              <a:t>SEBI Reg. INH000009807</a:t>
             </a:r>
             <a:endParaRPr sz="800" b="0" i="0" u="none" strike="noStrike" cap="none">
               <a:solidFill>
@@ -24628,7 +24628,7 @@
                 <a:cs typeface="Calibri"/>
                 <a:sym typeface="Calibri"/>
               </a:rPr>
-              <a:t>SEBI Reg. INH000009807                                                                                                                                                                                                                                                          </a:t>
+              <a:t>SEBI Reg. INH000009807</a:t>
             </a:r>
             <a:endParaRPr sz="800" b="0" i="0" u="none" strike="noStrike" cap="none">
               <a:solidFill>
@@ -25644,7 +25644,7 @@
                 <a:cs typeface="Calibri"/>
                 <a:sym typeface="Calibri"/>
               </a:rPr>
-              <a:t>SEBI Reg. INH000009807                                                                                                                                                                                                                                                          </a:t>
+              <a:t>SEBI Reg. INH000009807</a:t>
             </a:r>
             <a:endParaRPr sz="800" b="0" i="0" u="none" strike="noStrike" cap="none">
               <a:solidFill>
@@ -26310,7 +26310,7 @@
                 <a:cs typeface="Calibri"/>
                 <a:sym typeface="Calibri"/>
               </a:rPr>
-              <a:t>SEBI Reg. INH000009807                                                                                                                                                                                                                                                          </a:t>
+              <a:t>SEBI Reg. INH000009807</a:t>
             </a:r>
             <a:endParaRPr sz="800" b="0" i="0" u="none" strike="noStrike" cap="none">
               <a:solidFill>
@@ -28680,7 +28680,7 @@
                 <a:cs typeface="Calibri"/>
                 <a:sym typeface="Calibri"/>
               </a:rPr>
-              <a:t>SEBI Reg. INH000009807                                                                                                                                                                                                                                                          </a:t>
+              <a:t>SEBI Reg. INH000009807</a:t>
             </a:r>
             <a:endParaRPr sz="800" b="0" i="0" u="none" strike="noStrike" cap="none">
               <a:solidFill>
@@ -29157,7 +29157,7 @@
                 <a:cs typeface="Calibri"/>
                 <a:sym typeface="Calibri"/>
               </a:rPr>
-              <a:t>SEBI Reg. INH000009807                                                                                                                                                                                                                                                          </a:t>
+              <a:t>SEBI Reg. INH000009807</a:t>
             </a:r>
             <a:endParaRPr sz="800" b="0" i="0" u="none" strike="noStrike" cap="none">
               <a:solidFill>
@@ -30670,7 +30670,7 @@
                 <a:cs typeface="Calibri"/>
                 <a:sym typeface="Calibri"/>
               </a:rPr>
-              <a:t>SEBI Reg. INH000009807                                                                                                                                                                                                                                                          </a:t>
+              <a:t>SEBI Reg. INH000009807</a:t>
             </a:r>
             <a:endParaRPr sz="800" b="0" i="0" u="none" strike="noStrike" cap="none">
               <a:solidFill>
@@ -32857,7 +32857,7 @@
                 <a:cs typeface="Calibri"/>
                 <a:sym typeface="Calibri"/>
               </a:rPr>
-              <a:t>SEBI Reg. INH000009807                                                                                                                                                                                                                                                          </a:t>
+              <a:t>SEBI Reg. INH000009807</a:t>
             </a:r>
             <a:endParaRPr sz="800" b="0" i="0" u="none" strike="noStrike" cap="none">
               <a:solidFill>
@@ -34082,7 +34082,7 @@
                 <a:cs typeface="Calibri"/>
                 <a:sym typeface="Calibri"/>
               </a:rPr>
-              <a:t>SEBI Reg. INH000009807                                                                                                                                                                                                                                                          </a:t>
+              <a:t>SEBI Reg. INH000009807</a:t>
             </a:r>
             <a:endParaRPr sz="800" b="0" i="0" u="none" strike="noStrike" cap="none">
               <a:solidFill>
@@ -34466,7 +34466,7 @@
                 <a:cs typeface="Calibri"/>
                 <a:sym typeface="Calibri"/>
               </a:rPr>
-              <a:t>SEBI Reg. INH000009807                                                                                                                                                                                                                                                          </a:t>
+              <a:t>SEBI Reg. INH000009807</a:t>
             </a:r>
             <a:endParaRPr sz="800" b="0" i="0" u="none" strike="noStrike" cap="none">
               <a:solidFill>
@@ -34964,7 +34964,7 @@
                 <a:cs typeface="Calibri"/>
                 <a:sym typeface="Calibri"/>
               </a:rPr>
-              <a:t>SEBI Reg. INH000009807                                                                                                                                                                                                                                                          </a:t>
+              <a:t>SEBI Reg. INH000009807</a:t>
             </a:r>
             <a:endParaRPr sz="800" b="0" i="0" u="none" strike="noStrike" cap="none">
               <a:solidFill>
@@ -36353,7 +36353,7 @@
                 <a:cs typeface="Calibri"/>
                 <a:sym typeface="Calibri"/>
               </a:rPr>
-              <a:t>SEBI Reg. INH000009807                                                                                                                                                                                                                                                          </a:t>
+              <a:t>SEBI Reg. INH000009807</a:t>
             </a:r>
             <a:endParaRPr sz="800" b="0" i="0" u="none" strike="noStrike" cap="none">
               <a:solidFill>

</xml_diff>